<commit_message>
Intro deck: Non-Rayong overview slides in front, fresh screenshots, bigger logo
- Adds the eleven Non-Rayong overview 2026 slides (performance, site mix,
  hosts, cost reduction, operation excellence) redrawn in the Airy style,
  ahead of the nine app slides.
- Retakes every app screenshot from the latest main of both apps (night
  missions now show the midnight-blue fade; merge is the card stack).
- Bigger logo, no slide numbers, and the overlapping windows on the cover
  and the management slide are separated by a white mat and deeper shadow.
- Non-Rayong-Overview-2026.pptx holds all twenty slides; the apps-only
  TRIGO-apps-intro-deck.pptx is regenerated.

Co-Authored-By: Claude Opus 5.5 <noreply@anthropic.com>
Claude-Session: https://claude.ai/code/session_0136GmqE4GHPXYL2fF7t18DP
</commit_message>
<xml_diff>
--- a/design/intro-deck/TRIGO-apps-intro-deck.pptx
+++ b/design/intro-deck/TRIGO-apps-intro-deck.pptx
@@ -510,7 +510,7 @@
           <a:p>
             <a:r>
               <a:rPr lang="en-US" dirty="0"/>
-              <a:t>1 · Opening
+              <a:t>12 · The two apps
 Two internal tools, built for our sites. Same sign-in domain, same look, both installable on a phone.</a:t>
             </a:r>
             <a:endParaRPr lang="en-US" dirty="0"/>
@@ -599,8 +599,8 @@
           <a:p>
             <a:r>
               <a:rPr lang="en-US" dirty="0"/>
-              <a:t>2 · Manpower: the daily board
-Each card is a person, each column a mission with host, customer, shift and engineer. The tiles on top always add up: assigned plus leave plus standby equals total. The phone shows a day being merged: the carried-over plan beside the forecast, with each difference waiting for a decision.</a:t>
+              <a:t>13 · Manpower: the daily board
+Each card is a person, each column a mission with host, customer, shift and engineer. The tiles on top always add up: assigned plus leave plus standby equals total. The phone shows a forecast day being merged, one clash at a time: keep the carried-over plan or use the forecast.</a:t>
             </a:r>
             <a:endParaRPr lang="en-US" dirty="0"/>
           </a:p>
@@ -688,8 +688,8 @@
           <a:p>
             <a:r>
               <a:rPr lang="en-US" dirty="0"/>
-              <a:t>3 · Manpower: planning ahead
-Capacity compares demand per host with the people available. In the example, Monday 19/10 needs 40 against 36, so it shows 4 short.</a:t>
+              <a:t>14 · Manpower: planning ahead
+Capacity compares demand per host with the people available. In the example, Wednesday 21/10 needs 40 against 36, so it shows 4 short.</a:t>
             </a:r>
             <a:endParaRPr lang="en-US" dirty="0"/>
           </a:p>
@@ -777,7 +777,7 @@
           <a:p>
             <a:r>
               <a:rPr lang="en-US" dirty="0"/>
-              <a:t>4 · Manpower: what managers see
+              <a:t>15 · Manpower: what managers see
 Overview answers "is everyone placed?" first, then the numbers. Every chart has the exact figures on hover.</a:t>
             </a:r>
             <a:endParaRPr lang="en-US" dirty="0"/>
@@ -866,7 +866,7 @@
           <a:p>
             <a:r>
               <a:rPr lang="en-US" dirty="0"/>
-              <a:t>5 · Inventory: the system
+              <a:t>16 · Inventory: the system
 Rayong and Amata warehouses, one at a time or both. The dashboard opens on what needs attention: out of stock, calibration overdue, returns late, parts aged over 60 days.</a:t>
             </a:r>
             <a:endParaRPr lang="en-US" dirty="0"/>
@@ -955,7 +955,7 @@
           <a:p>
             <a:r>
               <a:rPr lang="en-US" dirty="0"/>
-              <a:t>6 · Inventory: the engineer's day
+              <a:t>17 · Inventory: the engineer's day
 The same flow works for consumables (issue from stock) and customer parts (deliveries in and out). Camera scanning works in Chrome and Edge; a handheld scanner works everywhere.</a:t>
             </a:r>
             <a:endParaRPr lang="en-US" dirty="0"/>
@@ -1044,7 +1044,7 @@
           <a:p>
             <a:r>
               <a:rPr lang="en-US" dirty="0"/>
-              <a:t>7 · Inventory: customer parts
+              <a:t>18 · Inventory: customer parts
 Parts are tracked by the customer's part number, mission number and responsible engineer. A delivery due today shows on the To-Do list and in the bell until someone confirms it.</a:t>
             </a:r>
             <a:endParaRPr lang="en-US" dirty="0"/>
@@ -1133,7 +1133,7 @@
           <a:p>
             <a:r>
               <a:rPr lang="en-US" dirty="0"/>
-              <a:t>8 · Inventory: for management
+              <a:t>19 · Inventory: for management
 Usage compares this period with the average of the previous three months. Open a site to see who issued what there. It is a fact to review, not a ranking of people.</a:t>
             </a:r>
             <a:endParaRPr lang="en-US" dirty="0"/>
@@ -1222,7 +1222,7 @@
           <a:p>
             <a:r>
               <a:rPr lang="en-US" dirty="0"/>
-              <a:t>9 · On your phone
+              <a:t>20 · On your phone
 New accounts are approved once by an admin. After installing, the app opens full screen from the home screen.</a:t>
             </a:r>
             <a:endParaRPr lang="en-US" dirty="0"/>
@@ -1638,7 +1638,7 @@
           <a:ln/>
         </p:spPr>
         <p:txBody>
-          <a:bodyPr wrap="square" lIns="0" tIns="0" rIns="0" bIns="0" rtlCol="0" anchor="t"/>
+          <a:bodyPr wrap="none" lIns="0" tIns="0" rIns="0" bIns="0" rtlCol="0" anchor="t"/>
           <a:lstStyle/>
           <a:p>
             <a:pPr algn="l" indent="0" marL="0">
@@ -1671,7 +1671,7 @@
         <p:spPr>
           <a:xfrm>
             <a:off x="457200" y="1463040"/>
-            <a:ext cx="4147718" cy="1600253"/>
+            <a:ext cx="4339742" cy="1600253"/>
           </a:xfrm>
           <a:prstGeom prst="rect">
             <a:avLst/>
@@ -1787,7 +1787,7 @@
         <p:spPr>
           <a:xfrm>
             <a:off x="457200" y="3100673"/>
-            <a:ext cx="3752698" cy="884682"/>
+            <a:ext cx="3926434" cy="884682"/>
           </a:xfrm>
           <a:prstGeom prst="rect">
             <a:avLst/>
@@ -1898,7 +1898,7 @@
           <a:ln/>
         </p:spPr>
         <p:txBody>
-          <a:bodyPr wrap="square" lIns="0" tIns="0" rIns="0" bIns="0" rtlCol="0" anchor="ctr"/>
+          <a:bodyPr wrap="none" lIns="0" tIns="0" rIns="0" bIns="0" rtlCol="0" anchor="ctr"/>
           <a:lstStyle/>
           <a:p>
             <a:pPr algn="l" indent="0" marL="0">
@@ -1940,7 +1940,7 @@
           <a:ln/>
         </p:spPr>
         <p:txBody>
-          <a:bodyPr wrap="square" lIns="0" tIns="0" rIns="0" bIns="0" rtlCol="0" anchor="ctr"/>
+          <a:bodyPr wrap="none" lIns="0" tIns="0" rIns="0" bIns="0" rtlCol="0" anchor="ctr"/>
           <a:lstStyle/>
           <a:p>
             <a:pPr algn="l" indent="0" marL="0">
@@ -1982,7 +1982,7 @@
           <a:ln/>
         </p:spPr>
         <p:txBody>
-          <a:bodyPr wrap="square" lIns="0" tIns="0" rIns="0" bIns="0" rtlCol="0" anchor="ctr"/>
+          <a:bodyPr wrap="none" lIns="0" tIns="0" rIns="0" bIns="0" rtlCol="0" anchor="ctr"/>
           <a:lstStyle/>
           <a:p>
             <a:pPr algn="l" indent="0" marL="0">
@@ -2080,7 +2080,7 @@
           <a:ln/>
         </p:spPr>
         <p:txBody>
-          <a:bodyPr wrap="square" lIns="0" tIns="0" rIns="0" bIns="0" rtlCol="0" anchor="t"/>
+          <a:bodyPr wrap="none" lIns="0" tIns="0" rIns="0" bIns="0" rtlCol="0" anchor="t"/>
           <a:lstStyle/>
           <a:p>
             <a:pPr algn="l" indent="0" marL="0">
@@ -2113,7 +2113,7 @@
         <p:spPr>
           <a:xfrm>
             <a:off x="457200" y="1426464"/>
-            <a:ext cx="3061411" cy="1199975"/>
+            <a:ext cx="3203143" cy="1199975"/>
           </a:xfrm>
           <a:prstGeom prst="rect">
             <a:avLst/>
@@ -2229,7 +2229,7 @@
         <p:spPr>
           <a:xfrm>
             <a:off x="457200" y="2663619"/>
-            <a:ext cx="3061411" cy="678942"/>
+            <a:ext cx="3203143" cy="678942"/>
           </a:xfrm>
           <a:prstGeom prst="rect">
             <a:avLst/>
@@ -2320,7 +2320,7 @@
           <a:ln/>
         </p:spPr>
         <p:txBody>
-          <a:bodyPr wrap="square" lIns="0" tIns="0" rIns="0" bIns="0" rtlCol="0" anchor="t"/>
+          <a:bodyPr wrap="none" lIns="0" tIns="0" rIns="0" bIns="0" rtlCol="0" anchor="t"/>
           <a:lstStyle/>
           <a:p>
             <a:pPr algn="l" indent="0" marL="0">
@@ -2362,7 +2362,7 @@
           <a:ln/>
         </p:spPr>
         <p:txBody>
-          <a:bodyPr wrap="square" lIns="0" tIns="0" rIns="0" bIns="0" rtlCol="0" anchor="t"/>
+          <a:bodyPr wrap="none" lIns="0" tIns="0" rIns="0" bIns="0" rtlCol="0" anchor="t"/>
           <a:lstStyle/>
           <a:p>
             <a:pPr algn="l" indent="0" marL="0">
@@ -2404,7 +2404,7 @@
           <a:ln/>
         </p:spPr>
         <p:txBody>
-          <a:bodyPr wrap="square" lIns="0" tIns="0" rIns="0" bIns="0" rtlCol="0" anchor="t"/>
+          <a:bodyPr wrap="none" lIns="0" tIns="0" rIns="0" bIns="0" rtlCol="0" anchor="t"/>
           <a:lstStyle/>
           <a:p>
             <a:pPr algn="l" indent="0" marL="0">
@@ -2446,7 +2446,7 @@
           <a:ln/>
         </p:spPr>
         <p:txBody>
-          <a:bodyPr wrap="square" lIns="0" tIns="0" rIns="0" bIns="0" rtlCol="0" anchor="t"/>
+          <a:bodyPr wrap="none" lIns="0" tIns="0" rIns="0" bIns="0" rtlCol="0" anchor="t"/>
           <a:lstStyle/>
           <a:p>
             <a:pPr algn="l" indent="0" marL="0">
@@ -2479,7 +2479,7 @@
         <p:spPr>
           <a:xfrm>
             <a:off x="877824" y="4052792"/>
-            <a:ext cx="2607137" cy="332576"/>
+            <a:ext cx="2727838" cy="332576"/>
           </a:xfrm>
           <a:prstGeom prst="rect">
             <a:avLst/>
@@ -2550,7 +2550,7 @@
           <a:ln/>
         </p:spPr>
         <p:txBody>
-          <a:bodyPr wrap="square" lIns="0" tIns="0" rIns="0" bIns="0" rtlCol="0" anchor="t"/>
+          <a:bodyPr wrap="none" lIns="0" tIns="0" rIns="0" bIns="0" rtlCol="0" anchor="t"/>
           <a:lstStyle/>
           <a:p>
             <a:pPr algn="l" indent="0" marL="0">
@@ -2648,7 +2648,7 @@
           <a:ln/>
         </p:spPr>
         <p:txBody>
-          <a:bodyPr wrap="square" lIns="0" tIns="0" rIns="0" bIns="0" rtlCol="0" anchor="t"/>
+          <a:bodyPr wrap="none" lIns="0" tIns="0" rIns="0" bIns="0" rtlCol="0" anchor="t"/>
           <a:lstStyle/>
           <a:p>
             <a:pPr algn="l" indent="0" marL="0">
@@ -2681,7 +2681,7 @@
         <p:spPr>
           <a:xfrm>
             <a:off x="457200" y="1426464"/>
-            <a:ext cx="3653942" cy="772243"/>
+            <a:ext cx="3823106" cy="772243"/>
           </a:xfrm>
           <a:prstGeom prst="rect">
             <a:avLst/>
@@ -2786,7 +2786,7 @@
           <a:ln/>
         </p:spPr>
         <p:txBody>
-          <a:bodyPr wrap="square" lIns="0" tIns="0" rIns="0" bIns="0" rtlCol="0" anchor="t"/>
+          <a:bodyPr wrap="none" lIns="0" tIns="0" rIns="0" bIns="0" rtlCol="0" anchor="t"/>
           <a:lstStyle/>
           <a:p>
             <a:pPr algn="l" indent="0" marL="0">
@@ -2828,7 +2828,7 @@
           <a:ln/>
         </p:spPr>
         <p:txBody>
-          <a:bodyPr wrap="square" lIns="0" tIns="0" rIns="0" bIns="0" rtlCol="0" anchor="t"/>
+          <a:bodyPr wrap="none" lIns="0" tIns="0" rIns="0" bIns="0" rtlCol="0" anchor="t"/>
           <a:lstStyle/>
           <a:p>
             <a:pPr algn="l" indent="0" marL="0">
@@ -2870,7 +2870,7 @@
           <a:ln/>
         </p:spPr>
         <p:txBody>
-          <a:bodyPr wrap="square" lIns="0" tIns="0" rIns="0" bIns="0" rtlCol="0" anchor="t"/>
+          <a:bodyPr wrap="none" lIns="0" tIns="0" rIns="0" bIns="0" rtlCol="0" anchor="t"/>
           <a:lstStyle/>
           <a:p>
             <a:pPr algn="l" indent="0" marL="0">
@@ -2912,7 +2912,7 @@
           <a:ln/>
         </p:spPr>
         <p:txBody>
-          <a:bodyPr wrap="square" lIns="0" tIns="0" rIns="0" bIns="0" rtlCol="0" anchor="t"/>
+          <a:bodyPr wrap="none" lIns="0" tIns="0" rIns="0" bIns="0" rtlCol="0" anchor="t"/>
           <a:lstStyle/>
           <a:p>
             <a:pPr algn="l" indent="0" marL="0">
@@ -2954,7 +2954,7 @@
           <a:ln/>
         </p:spPr>
         <p:txBody>
-          <a:bodyPr wrap="square" lIns="0" tIns="0" rIns="0" bIns="0" rtlCol="0" anchor="t"/>
+          <a:bodyPr wrap="none" lIns="0" tIns="0" rIns="0" bIns="0" rtlCol="0" anchor="t"/>
           <a:lstStyle/>
           <a:p>
             <a:pPr algn="l" indent="0" marL="0">
@@ -2996,7 +2996,7 @@
           <a:ln/>
         </p:spPr>
         <p:txBody>
-          <a:bodyPr wrap="square" lIns="0" tIns="0" rIns="0" bIns="0" rtlCol="0" anchor="t"/>
+          <a:bodyPr wrap="none" lIns="0" tIns="0" rIns="0" bIns="0" rtlCol="0" anchor="t"/>
           <a:lstStyle/>
           <a:p>
             <a:pPr algn="l" indent="0" marL="0">
@@ -3038,7 +3038,7 @@
           <a:ln/>
         </p:spPr>
         <p:txBody>
-          <a:bodyPr wrap="square" lIns="0" tIns="0" rIns="0" bIns="0" rtlCol="0" anchor="t"/>
+          <a:bodyPr wrap="none" lIns="0" tIns="0" rIns="0" bIns="0" rtlCol="0" anchor="t"/>
           <a:lstStyle/>
           <a:p>
             <a:pPr algn="l" indent="0" marL="0">
@@ -3080,7 +3080,7 @@
           <a:ln/>
         </p:spPr>
         <p:txBody>
-          <a:bodyPr wrap="square" lIns="0" tIns="0" rIns="0" bIns="0" rtlCol="0" anchor="t"/>
+          <a:bodyPr wrap="none" lIns="0" tIns="0" rIns="0" bIns="0" rtlCol="0" anchor="t"/>
           <a:lstStyle/>
           <a:p>
             <a:pPr algn="l" indent="0" marL="0">
@@ -3122,7 +3122,7 @@
           <a:ln/>
         </p:spPr>
         <p:txBody>
-          <a:bodyPr wrap="square" lIns="0" tIns="0" rIns="0" bIns="0" rtlCol="0" anchor="t"/>
+          <a:bodyPr wrap="none" lIns="0" tIns="0" rIns="0" bIns="0" rtlCol="0" anchor="t"/>
           <a:lstStyle/>
           <a:p>
             <a:pPr algn="l" indent="0" marL="0">
@@ -3164,7 +3164,7 @@
           <a:ln/>
         </p:spPr>
         <p:txBody>
-          <a:bodyPr wrap="square" lIns="0" tIns="0" rIns="0" bIns="0" rtlCol="0" anchor="t"/>
+          <a:bodyPr wrap="none" lIns="0" tIns="0" rIns="0" bIns="0" rtlCol="0" anchor="t"/>
           <a:lstStyle/>
           <a:p>
             <a:pPr algn="l" indent="0" marL="0">
@@ -3197,7 +3197,7 @@
         <p:spPr>
           <a:xfrm>
             <a:off x="4389120" y="4374404"/>
-            <a:ext cx="2212116" cy="520522"/>
+            <a:ext cx="2314529" cy="520522"/>
           </a:xfrm>
           <a:prstGeom prst="rect">
             <a:avLst/>
@@ -3279,7 +3279,7 @@
         <p:spPr>
           <a:xfrm>
             <a:off x="6638544" y="4374404"/>
-            <a:ext cx="2212116" cy="520522"/>
+            <a:ext cx="2314529" cy="520522"/>
           </a:xfrm>
           <a:prstGeom prst="rect">
             <a:avLst/>
@@ -3426,7 +3426,7 @@
           <a:ln/>
         </p:spPr>
         <p:txBody>
-          <a:bodyPr wrap="square" lIns="0" tIns="0" rIns="0" bIns="0" rtlCol="0" anchor="t"/>
+          <a:bodyPr wrap="none" lIns="0" tIns="0" rIns="0" bIns="0" rtlCol="0" anchor="t"/>
           <a:lstStyle/>
           <a:p>
             <a:pPr algn="l" indent="0" marL="0">
@@ -3459,7 +3459,7 @@
         <p:spPr>
           <a:xfrm>
             <a:off x="457200" y="1426464"/>
-            <a:ext cx="3258922" cy="772243"/>
+            <a:ext cx="3409798" cy="772243"/>
           </a:xfrm>
           <a:prstGeom prst="rect">
             <a:avLst/>
@@ -3564,7 +3564,7 @@
           <a:ln/>
         </p:spPr>
         <p:txBody>
-          <a:bodyPr wrap="square" lIns="0" tIns="0" rIns="0" bIns="0" rtlCol="0" anchor="t"/>
+          <a:bodyPr wrap="none" lIns="0" tIns="0" rIns="0" bIns="0" rtlCol="0" anchor="t"/>
           <a:lstStyle/>
           <a:p>
             <a:pPr algn="l" indent="0" marL="0">
@@ -3606,7 +3606,7 @@
           <a:ln/>
         </p:spPr>
         <p:txBody>
-          <a:bodyPr wrap="square" lIns="0" tIns="0" rIns="0" bIns="0" rtlCol="0" anchor="t"/>
+          <a:bodyPr wrap="none" lIns="0" tIns="0" rIns="0" bIns="0" rtlCol="0" anchor="t"/>
           <a:lstStyle/>
           <a:p>
             <a:pPr algn="l" indent="0" marL="0">
@@ -3648,7 +3648,7 @@
           <a:ln/>
         </p:spPr>
         <p:txBody>
-          <a:bodyPr wrap="square" lIns="0" tIns="0" rIns="0" bIns="0" rtlCol="0" anchor="t"/>
+          <a:bodyPr wrap="none" lIns="0" tIns="0" rIns="0" bIns="0" rtlCol="0" anchor="t"/>
           <a:lstStyle/>
           <a:p>
             <a:pPr algn="l" indent="0" marL="0">
@@ -3690,7 +3690,7 @@
           <a:ln/>
         </p:spPr>
         <p:txBody>
-          <a:bodyPr wrap="square" lIns="0" tIns="0" rIns="0" bIns="0" rtlCol="0" anchor="t"/>
+          <a:bodyPr wrap="none" lIns="0" tIns="0" rIns="0" bIns="0" rtlCol="0" anchor="t"/>
           <a:lstStyle/>
           <a:p>
             <a:pPr algn="l" indent="0" marL="0">
@@ -3732,7 +3732,7 @@
           <a:ln/>
         </p:spPr>
         <p:txBody>
-          <a:bodyPr wrap="square" lIns="0" tIns="0" rIns="0" bIns="0" rtlCol="0" anchor="t"/>
+          <a:bodyPr wrap="none" lIns="0" tIns="0" rIns="0" bIns="0" rtlCol="0" anchor="t"/>
           <a:lstStyle/>
           <a:p>
             <a:pPr algn="l" indent="0" marL="0">
@@ -3774,7 +3774,7 @@
           <a:ln/>
         </p:spPr>
         <p:txBody>
-          <a:bodyPr wrap="square" lIns="0" tIns="0" rIns="0" bIns="0" rtlCol="0" anchor="t"/>
+          <a:bodyPr wrap="none" lIns="0" tIns="0" rIns="0" bIns="0" rtlCol="0" anchor="t"/>
           <a:lstStyle/>
           <a:p>
             <a:pPr algn="l" indent="0" marL="0">
@@ -3816,7 +3816,7 @@
           <a:ln/>
         </p:spPr>
         <p:txBody>
-          <a:bodyPr wrap="square" lIns="0" tIns="0" rIns="0" bIns="0" rtlCol="0" anchor="t"/>
+          <a:bodyPr wrap="none" lIns="0" tIns="0" rIns="0" bIns="0" rtlCol="0" anchor="t"/>
           <a:lstStyle/>
           <a:p>
             <a:pPr algn="l" indent="0" marL="0">
@@ -3858,7 +3858,7 @@
           <a:ln/>
         </p:spPr>
         <p:txBody>
-          <a:bodyPr wrap="square" lIns="0" tIns="0" rIns="0" bIns="0" rtlCol="0" anchor="t"/>
+          <a:bodyPr wrap="none" lIns="0" tIns="0" rIns="0" bIns="0" rtlCol="0" anchor="t"/>
           <a:lstStyle/>
           <a:p>
             <a:pPr algn="l" indent="0" marL="0">
@@ -3956,7 +3956,7 @@
           <a:ln/>
         </p:spPr>
         <p:txBody>
-          <a:bodyPr wrap="square" lIns="0" tIns="0" rIns="0" bIns="0" rtlCol="0" anchor="t"/>
+          <a:bodyPr wrap="none" lIns="0" tIns="0" rIns="0" bIns="0" rtlCol="0" anchor="t"/>
           <a:lstStyle/>
           <a:p>
             <a:pPr algn="l" indent="0" marL="0">
@@ -3989,7 +3989,7 @@
         <p:spPr>
           <a:xfrm>
             <a:off x="5486400" y="1426464"/>
-            <a:ext cx="3456432" cy="1076912"/>
+            <a:ext cx="3616452" cy="1076912"/>
           </a:xfrm>
           <a:prstGeom prst="rect">
             <a:avLst/>
@@ -4097,7 +4097,7 @@
           <a:ln/>
         </p:spPr>
         <p:txBody>
-          <a:bodyPr wrap="square" lIns="0" tIns="0" rIns="0" bIns="0" rtlCol="0" anchor="t"/>
+          <a:bodyPr wrap="none" lIns="0" tIns="0" rIns="0" bIns="0" rtlCol="0" anchor="t"/>
           <a:lstStyle/>
           <a:p>
             <a:pPr algn="l" indent="0" marL="0">
@@ -4139,7 +4139,7 @@
           <a:ln/>
         </p:spPr>
         <p:txBody>
-          <a:bodyPr wrap="square" lIns="0" tIns="0" rIns="0" bIns="0" rtlCol="0" anchor="t"/>
+          <a:bodyPr wrap="none" lIns="0" tIns="0" rIns="0" bIns="0" rtlCol="0" anchor="t"/>
           <a:lstStyle/>
           <a:p>
             <a:pPr algn="l" indent="0" marL="0">
@@ -4181,7 +4181,7 @@
           <a:ln/>
         </p:spPr>
         <p:txBody>
-          <a:bodyPr wrap="square" lIns="0" tIns="0" rIns="0" bIns="0" rtlCol="0" anchor="t"/>
+          <a:bodyPr wrap="none" lIns="0" tIns="0" rIns="0" bIns="0" rtlCol="0" anchor="t"/>
           <a:lstStyle/>
           <a:p>
             <a:pPr algn="l" indent="0" marL="0">
@@ -4223,7 +4223,7 @@
           <a:ln/>
         </p:spPr>
         <p:txBody>
-          <a:bodyPr wrap="square" lIns="0" tIns="0" rIns="0" bIns="0" rtlCol="0" anchor="t"/>
+          <a:bodyPr wrap="none" lIns="0" tIns="0" rIns="0" bIns="0" rtlCol="0" anchor="t"/>
           <a:lstStyle/>
           <a:p>
             <a:pPr algn="l" indent="0" marL="0">
@@ -4265,7 +4265,7 @@
           <a:ln/>
         </p:spPr>
         <p:txBody>
-          <a:bodyPr wrap="square" lIns="0" tIns="0" rIns="0" bIns="0" rtlCol="0" anchor="t"/>
+          <a:bodyPr wrap="none" lIns="0" tIns="0" rIns="0" bIns="0" rtlCol="0" anchor="t"/>
           <a:lstStyle/>
           <a:p>
             <a:pPr algn="l" indent="0" marL="0">
@@ -4307,7 +4307,7 @@
           <a:ln/>
         </p:spPr>
         <p:txBody>
-          <a:bodyPr wrap="square" lIns="0" tIns="0" rIns="0" bIns="0" rtlCol="0" anchor="t"/>
+          <a:bodyPr wrap="none" lIns="0" tIns="0" rIns="0" bIns="0" rtlCol="0" anchor="t"/>
           <a:lstStyle/>
           <a:p>
             <a:pPr algn="l" indent="0" marL="0">
@@ -4349,7 +4349,7 @@
           <a:ln/>
         </p:spPr>
         <p:txBody>
-          <a:bodyPr wrap="square" lIns="0" tIns="0" rIns="0" bIns="0" rtlCol="0" anchor="t"/>
+          <a:bodyPr wrap="none" lIns="0" tIns="0" rIns="0" bIns="0" rtlCol="0" anchor="t"/>
           <a:lstStyle/>
           <a:p>
             <a:pPr algn="l" indent="0" marL="0">
@@ -4391,7 +4391,7 @@
           <a:ln/>
         </p:spPr>
         <p:txBody>
-          <a:bodyPr wrap="square" lIns="0" tIns="0" rIns="0" bIns="0" rtlCol="0" anchor="t"/>
+          <a:bodyPr wrap="none" lIns="0" tIns="0" rIns="0" bIns="0" rtlCol="0" anchor="t"/>
           <a:lstStyle/>
           <a:p>
             <a:pPr algn="l" indent="0" marL="0">
@@ -4489,7 +4489,7 @@
           <a:ln/>
         </p:spPr>
         <p:txBody>
-          <a:bodyPr wrap="square" lIns="0" tIns="0" rIns="0" bIns="0" rtlCol="0" anchor="t"/>
+          <a:bodyPr wrap="none" lIns="0" tIns="0" rIns="0" bIns="0" rtlCol="0" anchor="t"/>
           <a:lstStyle/>
           <a:p>
             <a:pPr algn="l" indent="0" marL="0">
@@ -4522,7 +4522,7 @@
         <p:spPr>
           <a:xfrm>
             <a:off x="457200" y="1426464"/>
-            <a:ext cx="3357677" cy="772243"/>
+            <a:ext cx="3513125" cy="772243"/>
           </a:xfrm>
           <a:prstGeom prst="rect">
             <a:avLst/>
@@ -4627,7 +4627,7 @@
           <a:ln/>
         </p:spPr>
         <p:txBody>
-          <a:bodyPr wrap="square" lIns="0" tIns="0" rIns="0" bIns="0" rtlCol="0" anchor="t"/>
+          <a:bodyPr wrap="none" lIns="0" tIns="0" rIns="0" bIns="0" rtlCol="0" anchor="t"/>
           <a:lstStyle/>
           <a:p>
             <a:pPr algn="l" indent="0" marL="0">
@@ -4669,7 +4669,7 @@
           <a:ln/>
         </p:spPr>
         <p:txBody>
-          <a:bodyPr wrap="square" lIns="0" tIns="0" rIns="0" bIns="0" rtlCol="0" anchor="t"/>
+          <a:bodyPr wrap="none" lIns="0" tIns="0" rIns="0" bIns="0" rtlCol="0" anchor="t"/>
           <a:lstStyle/>
           <a:p>
             <a:pPr algn="l" indent="0" marL="0">
@@ -4711,7 +4711,7 @@
           <a:ln/>
         </p:spPr>
         <p:txBody>
-          <a:bodyPr wrap="square" lIns="0" tIns="0" rIns="0" bIns="0" rtlCol="0" anchor="t"/>
+          <a:bodyPr wrap="none" lIns="0" tIns="0" rIns="0" bIns="0" rtlCol="0" anchor="t"/>
           <a:lstStyle/>
           <a:p>
             <a:pPr algn="l" indent="0" marL="0">
@@ -4753,7 +4753,7 @@
           <a:ln/>
         </p:spPr>
         <p:txBody>
-          <a:bodyPr wrap="square" lIns="0" tIns="0" rIns="0" bIns="0" rtlCol="0" anchor="t"/>
+          <a:bodyPr wrap="none" lIns="0" tIns="0" rIns="0" bIns="0" rtlCol="0" anchor="t"/>
           <a:lstStyle/>
           <a:p>
             <a:pPr algn="l" indent="0" marL="0">
@@ -4795,7 +4795,7 @@
           <a:ln/>
         </p:spPr>
         <p:txBody>
-          <a:bodyPr wrap="square" lIns="0" tIns="0" rIns="0" bIns="0" rtlCol="0" anchor="t"/>
+          <a:bodyPr wrap="none" lIns="0" tIns="0" rIns="0" bIns="0" rtlCol="0" anchor="t"/>
           <a:lstStyle/>
           <a:p>
             <a:pPr algn="l" indent="0" marL="0">
@@ -4837,7 +4837,7 @@
           <a:ln/>
         </p:spPr>
         <p:txBody>
-          <a:bodyPr wrap="square" lIns="0" tIns="0" rIns="0" bIns="0" rtlCol="0" anchor="t"/>
+          <a:bodyPr wrap="none" lIns="0" tIns="0" rIns="0" bIns="0" rtlCol="0" anchor="t"/>
           <a:lstStyle/>
           <a:p>
             <a:pPr algn="l" indent="0" marL="0">
@@ -4879,7 +4879,7 @@
           <a:ln/>
         </p:spPr>
         <p:txBody>
-          <a:bodyPr wrap="square" lIns="0" tIns="0" rIns="0" bIns="0" rtlCol="0" anchor="t"/>
+          <a:bodyPr wrap="none" lIns="0" tIns="0" rIns="0" bIns="0" rtlCol="0" anchor="t"/>
           <a:lstStyle/>
           <a:p>
             <a:pPr algn="l" indent="0" marL="0">
@@ -4921,7 +4921,7 @@
           <a:ln/>
         </p:spPr>
         <p:txBody>
-          <a:bodyPr wrap="square" lIns="0" tIns="0" rIns="0" bIns="0" rtlCol="0" anchor="t"/>
+          <a:bodyPr wrap="none" lIns="0" tIns="0" rIns="0" bIns="0" rtlCol="0" anchor="t"/>
           <a:lstStyle/>
           <a:p>
             <a:pPr algn="l" indent="0" marL="0">
@@ -5019,7 +5019,7 @@
           <a:ln/>
         </p:spPr>
         <p:txBody>
-          <a:bodyPr wrap="square" lIns="0" tIns="0" rIns="0" bIns="0" rtlCol="0" anchor="t"/>
+          <a:bodyPr wrap="none" lIns="0" tIns="0" rIns="0" bIns="0" rtlCol="0" anchor="t"/>
           <a:lstStyle/>
           <a:p>
             <a:pPr algn="l" indent="0" marL="0">
@@ -5052,7 +5052,7 @@
         <p:spPr>
           <a:xfrm>
             <a:off x="5486400" y="1426464"/>
-            <a:ext cx="3456432" cy="750585"/>
+            <a:ext cx="3616452" cy="750585"/>
           </a:xfrm>
           <a:prstGeom prst="rect">
             <a:avLst/>
@@ -5174,7 +5174,7 @@
           <a:ln/>
         </p:spPr>
         <p:txBody>
-          <a:bodyPr wrap="square" lIns="0" tIns="0" rIns="0" bIns="0" rtlCol="0" anchor="t"/>
+          <a:bodyPr wrap="none" lIns="0" tIns="0" rIns="0" bIns="0" rtlCol="0" anchor="t"/>
           <a:lstStyle/>
           <a:p>
             <a:pPr algn="l" indent="0" marL="0">
@@ -5216,7 +5216,7 @@
           <a:ln/>
         </p:spPr>
         <p:txBody>
-          <a:bodyPr wrap="square" lIns="0" tIns="0" rIns="0" bIns="0" rtlCol="0" anchor="t"/>
+          <a:bodyPr wrap="none" lIns="0" tIns="0" rIns="0" bIns="0" rtlCol="0" anchor="t"/>
           <a:lstStyle/>
           <a:p>
             <a:pPr algn="l" indent="0" marL="0">
@@ -5258,7 +5258,7 @@
           <a:ln/>
         </p:spPr>
         <p:txBody>
-          <a:bodyPr wrap="square" lIns="0" tIns="0" rIns="0" bIns="0" rtlCol="0" anchor="t"/>
+          <a:bodyPr wrap="none" lIns="0" tIns="0" rIns="0" bIns="0" rtlCol="0" anchor="t"/>
           <a:lstStyle/>
           <a:p>
             <a:pPr algn="l" indent="0" marL="0">
@@ -5300,7 +5300,7 @@
           <a:ln/>
         </p:spPr>
         <p:txBody>
-          <a:bodyPr wrap="square" lIns="0" tIns="0" rIns="0" bIns="0" rtlCol="0" anchor="t"/>
+          <a:bodyPr wrap="none" lIns="0" tIns="0" rIns="0" bIns="0" rtlCol="0" anchor="t"/>
           <a:lstStyle/>
           <a:p>
             <a:pPr algn="l" indent="0" marL="0">
@@ -5342,7 +5342,7 @@
           <a:ln/>
         </p:spPr>
         <p:txBody>
-          <a:bodyPr wrap="square" lIns="0" tIns="0" rIns="0" bIns="0" rtlCol="0" anchor="t"/>
+          <a:bodyPr wrap="none" lIns="0" tIns="0" rIns="0" bIns="0" rtlCol="0" anchor="t"/>
           <a:lstStyle/>
           <a:p>
             <a:pPr algn="l" indent="0" marL="0">
@@ -5384,7 +5384,7 @@
           <a:ln/>
         </p:spPr>
         <p:txBody>
-          <a:bodyPr wrap="square" lIns="0" tIns="0" rIns="0" bIns="0" rtlCol="0" anchor="t"/>
+          <a:bodyPr wrap="none" lIns="0" tIns="0" rIns="0" bIns="0" rtlCol="0" anchor="t"/>
           <a:lstStyle/>
           <a:p>
             <a:pPr algn="l" indent="0" marL="0">
@@ -5417,7 +5417,7 @@
         <p:spPr>
           <a:xfrm>
             <a:off x="5907024" y="3276267"/>
-            <a:ext cx="3002158" cy="332576"/>
+            <a:ext cx="3141147" cy="332576"/>
           </a:xfrm>
           <a:prstGeom prst="rect">
             <a:avLst/>
@@ -5488,7 +5488,7 @@
           <a:ln/>
         </p:spPr>
         <p:txBody>
-          <a:bodyPr wrap="square" lIns="0" tIns="0" rIns="0" bIns="0" rtlCol="0" anchor="t"/>
+          <a:bodyPr wrap="none" lIns="0" tIns="0" rIns="0" bIns="0" rtlCol="0" anchor="t"/>
           <a:lstStyle/>
           <a:p>
             <a:pPr algn="l" indent="0" marL="0">
@@ -5586,7 +5586,7 @@
           <a:ln/>
         </p:spPr>
         <p:txBody>
-          <a:bodyPr wrap="square" lIns="0" tIns="0" rIns="0" bIns="0" rtlCol="0" anchor="t"/>
+          <a:bodyPr wrap="none" lIns="0" tIns="0" rIns="0" bIns="0" rtlCol="0" anchor="t"/>
           <a:lstStyle/>
           <a:p>
             <a:pPr algn="l" indent="0" marL="0">
@@ -5619,7 +5619,7 @@
         <p:spPr>
           <a:xfrm>
             <a:off x="457200" y="1426464"/>
-            <a:ext cx="3555187" cy="750585"/>
+            <a:ext cx="3719779" cy="750585"/>
           </a:xfrm>
           <a:prstGeom prst="rect">
             <a:avLst/>
@@ -5724,7 +5724,7 @@
           <a:ln/>
         </p:spPr>
         <p:txBody>
-          <a:bodyPr wrap="square" lIns="0" tIns="0" rIns="0" bIns="0" rtlCol="0" anchor="t"/>
+          <a:bodyPr wrap="none" lIns="0" tIns="0" rIns="0" bIns="0" rtlCol="0" anchor="t"/>
           <a:lstStyle/>
           <a:p>
             <a:pPr algn="l" indent="0" marL="0">
@@ -5766,7 +5766,7 @@
           <a:ln/>
         </p:spPr>
         <p:txBody>
-          <a:bodyPr wrap="square" lIns="0" tIns="0" rIns="0" bIns="0" rtlCol="0" anchor="t"/>
+          <a:bodyPr wrap="none" lIns="0" tIns="0" rIns="0" bIns="0" rtlCol="0" anchor="t"/>
           <a:lstStyle/>
           <a:p>
             <a:pPr algn="l" indent="0" marL="0">
@@ -5808,7 +5808,7 @@
           <a:ln/>
         </p:spPr>
         <p:txBody>
-          <a:bodyPr wrap="square" lIns="0" tIns="0" rIns="0" bIns="0" rtlCol="0" anchor="t"/>
+          <a:bodyPr wrap="none" lIns="0" tIns="0" rIns="0" bIns="0" rtlCol="0" anchor="t"/>
           <a:lstStyle/>
           <a:p>
             <a:pPr algn="l" indent="0" marL="0">
@@ -5850,7 +5850,7 @@
           <a:ln/>
         </p:spPr>
         <p:txBody>
-          <a:bodyPr wrap="square" lIns="0" tIns="0" rIns="0" bIns="0" rtlCol="0" anchor="t"/>
+          <a:bodyPr wrap="none" lIns="0" tIns="0" rIns="0" bIns="0" rtlCol="0" anchor="t"/>
           <a:lstStyle/>
           <a:p>
             <a:pPr algn="l" indent="0" marL="0">
@@ -5892,7 +5892,7 @@
           <a:ln/>
         </p:spPr>
         <p:txBody>
-          <a:bodyPr wrap="square" lIns="0" tIns="0" rIns="0" bIns="0" rtlCol="0" anchor="t"/>
+          <a:bodyPr wrap="none" lIns="0" tIns="0" rIns="0" bIns="0" rtlCol="0" anchor="t"/>
           <a:lstStyle/>
           <a:p>
             <a:pPr algn="l" indent="0" marL="0">
@@ -5934,7 +5934,7 @@
           <a:ln/>
         </p:spPr>
         <p:txBody>
-          <a:bodyPr wrap="square" lIns="0" tIns="0" rIns="0" bIns="0" rtlCol="0" anchor="t"/>
+          <a:bodyPr wrap="none" lIns="0" tIns="0" rIns="0" bIns="0" rtlCol="0" anchor="t"/>
           <a:lstStyle/>
           <a:p>
             <a:pPr algn="l" indent="0" marL="0">
@@ -5976,7 +5976,7 @@
           <a:ln/>
         </p:spPr>
         <p:txBody>
-          <a:bodyPr wrap="square" lIns="0" tIns="0" rIns="0" bIns="0" rtlCol="0" anchor="t"/>
+          <a:bodyPr wrap="none" lIns="0" tIns="0" rIns="0" bIns="0" rtlCol="0" anchor="t"/>
           <a:lstStyle/>
           <a:p>
             <a:pPr algn="l" indent="0" marL="0">
@@ -6018,7 +6018,7 @@
           <a:ln/>
         </p:spPr>
         <p:txBody>
-          <a:bodyPr wrap="square" lIns="0" tIns="0" rIns="0" bIns="0" rtlCol="0" anchor="t"/>
+          <a:bodyPr wrap="none" lIns="0" tIns="0" rIns="0" bIns="0" rtlCol="0" anchor="t"/>
           <a:lstStyle/>
           <a:p>
             <a:pPr algn="l" indent="0" marL="0">
@@ -6116,7 +6116,7 @@
           <a:ln/>
         </p:spPr>
         <p:txBody>
-          <a:bodyPr wrap="square" lIns="0" tIns="0" rIns="0" bIns="0" rtlCol="0" anchor="t"/>
+          <a:bodyPr wrap="none" lIns="0" tIns="0" rIns="0" bIns="0" rtlCol="0" anchor="t"/>
           <a:lstStyle/>
           <a:p>
             <a:pPr algn="l" indent="0" marL="0">
@@ -6149,7 +6149,7 @@
         <p:spPr>
           <a:xfrm>
             <a:off x="457200" y="1444752"/>
-            <a:ext cx="3456432" cy="943789"/>
+            <a:ext cx="3616452" cy="943789"/>
           </a:xfrm>
           <a:prstGeom prst="rect">
             <a:avLst/>
@@ -6228,7 +6228,7 @@
         <p:spPr>
           <a:xfrm>
             <a:off x="457200" y="2430018"/>
-            <a:ext cx="3456432" cy="678942"/>
+            <a:ext cx="3616452" cy="678942"/>
           </a:xfrm>
           <a:prstGeom prst="rect">
             <a:avLst/>
@@ -6319,7 +6319,7 @@
           <a:ln/>
         </p:spPr>
         <p:txBody>
-          <a:bodyPr wrap="square" lIns="0" tIns="0" rIns="0" bIns="0" rtlCol="0" anchor="t"/>
+          <a:bodyPr wrap="none" lIns="0" tIns="0" rIns="0" bIns="0" rtlCol="0" anchor="t"/>
           <a:lstStyle/>
           <a:p>
             <a:pPr algn="l" indent="0" marL="0">
@@ -6361,7 +6361,7 @@
           <a:ln/>
         </p:spPr>
         <p:txBody>
-          <a:bodyPr wrap="square" lIns="0" tIns="0" rIns="0" bIns="0" rtlCol="0" anchor="t"/>
+          <a:bodyPr wrap="none" lIns="0" tIns="0" rIns="0" bIns="0" rtlCol="0" anchor="t"/>
           <a:lstStyle/>
           <a:p>
             <a:pPr algn="l" indent="0" marL="0">
@@ -6403,7 +6403,7 @@
           <a:ln/>
         </p:spPr>
         <p:txBody>
-          <a:bodyPr wrap="square" lIns="0" tIns="0" rIns="0" bIns="0" rtlCol="0" anchor="t"/>
+          <a:bodyPr wrap="none" lIns="0" tIns="0" rIns="0" bIns="0" rtlCol="0" anchor="t"/>
           <a:lstStyle/>
           <a:p>
             <a:pPr algn="l" indent="0" marL="0">
@@ -6436,7 +6436,7 @@
         <p:spPr>
           <a:xfrm>
             <a:off x="868680" y="3284982"/>
-            <a:ext cx="3012034" cy="365771"/>
+            <a:ext cx="3151480" cy="365771"/>
           </a:xfrm>
           <a:prstGeom prst="rect">
             <a:avLst/>
@@ -6524,7 +6524,7 @@
           <a:ln/>
         </p:spPr>
         <p:txBody>
-          <a:bodyPr wrap="square" lIns="0" tIns="0" rIns="0" bIns="0" rtlCol="0" anchor="t"/>
+          <a:bodyPr wrap="none" lIns="0" tIns="0" rIns="0" bIns="0" rtlCol="0" anchor="t"/>
           <a:lstStyle/>
           <a:p>
             <a:pPr algn="l" indent="0" marL="0">
@@ -6583,7 +6583,7 @@
           <a:ln/>
         </p:spPr>
         <p:txBody>
-          <a:bodyPr wrap="square" lIns="0" tIns="0" rIns="0" bIns="0" rtlCol="0" anchor="t"/>
+          <a:bodyPr wrap="none" lIns="0" tIns="0" rIns="0" bIns="0" rtlCol="0" anchor="t"/>
           <a:lstStyle/>
           <a:p>
             <a:pPr algn="l" indent="0" marL="0">
@@ -6642,7 +6642,7 @@
           <a:ln/>
         </p:spPr>
         <p:txBody>
-          <a:bodyPr wrap="square" lIns="0" tIns="0" rIns="0" bIns="0" rtlCol="0" anchor="t"/>
+          <a:bodyPr wrap="none" lIns="0" tIns="0" rIns="0" bIns="0" rtlCol="0" anchor="t"/>
           <a:lstStyle/>
           <a:p>
             <a:pPr algn="l" indent="0" marL="0">
@@ -6684,7 +6684,7 @@
           <a:ln/>
         </p:spPr>
         <p:txBody>
-          <a:bodyPr wrap="square" lIns="0" tIns="0" rIns="0" bIns="0" rtlCol="0" anchor="t"/>
+          <a:bodyPr wrap="none" lIns="0" tIns="0" rIns="0" bIns="0" rtlCol="0" anchor="t"/>
           <a:lstStyle/>
           <a:p>
             <a:pPr algn="l" indent="0" marL="0">
@@ -6726,7 +6726,7 @@
           <a:ln/>
         </p:spPr>
         <p:txBody>
-          <a:bodyPr wrap="square" lIns="0" tIns="0" rIns="0" bIns="0" rtlCol="0" anchor="ctr"/>
+          <a:bodyPr wrap="none" lIns="0" tIns="0" rIns="0" bIns="0" rtlCol="0" anchor="ctr"/>
           <a:lstStyle/>
           <a:p>
             <a:pPr algn="l" indent="0" marL="0">
@@ -6768,7 +6768,7 @@
           <a:ln/>
         </p:spPr>
         <p:txBody>
-          <a:bodyPr wrap="square" lIns="0" tIns="0" rIns="0" bIns="0" rtlCol="0" anchor="ctr"/>
+          <a:bodyPr wrap="none" lIns="0" tIns="0" rIns="0" bIns="0" rtlCol="0" anchor="ctr"/>
           <a:lstStyle/>
           <a:p>
             <a:pPr algn="l" indent="0" marL="0">
@@ -6810,7 +6810,7 @@
           <a:ln/>
         </p:spPr>
         <p:txBody>
-          <a:bodyPr wrap="square" lIns="0" tIns="0" rIns="0" bIns="0" rtlCol="0" anchor="ctr"/>
+          <a:bodyPr wrap="none" lIns="0" tIns="0" rIns="0" bIns="0" rtlCol="0" anchor="ctr"/>
           <a:lstStyle/>
           <a:p>
             <a:pPr algn="ctr" indent="0" marL="0">
@@ -6852,7 +6852,7 @@
           <a:ln/>
         </p:spPr>
         <p:txBody>
-          <a:bodyPr wrap="square" lIns="0" tIns="0" rIns="0" bIns="0" rtlCol="0" anchor="ctr"/>
+          <a:bodyPr wrap="none" lIns="0" tIns="0" rIns="0" bIns="0" rtlCol="0" anchor="ctr"/>
           <a:lstStyle/>
           <a:p>
             <a:pPr algn="ctr" indent="0" marL="0">

</xml_diff>